<commit_message>
feat: update .gitignore to include new render files and cache for improved asset management
</commit_message>
<xml_diff>
--- a/docs/NeuroSync-Slide1-Submission.pptx
+++ b/docs/NeuroSync-Slide1-Submission.pptx
@@ -5,9 +5,9 @@
     <p:sldMasterId id="2147483648" r:id="rId1"/>
   </p:sldMasterIdLst>
   <p:sldIdLst>
-    <p:sldId id="256" r:id="rId7"/>
+    <p:sldId id="256" r:id="rId2"/>
   </p:sldIdLst>
-  <p:sldSz cx="12191695" cy="6858000" type="screen4x3"/>
+  <p:sldSz cx="12192000" cy="6858000"/>
   <p:notesSz cx="6858000" cy="9144000"/>
   <p:defaultTextStyle>
     <a:defPPr>
@@ -104,6 +104,22 @@
       </a:defRPr>
     </a:lvl9pPr>
   </p:defaultTextStyle>
+  <p:extLst>
+    <p:ext uri="{EFAFB233-063F-42B5-8137-9DF3F51BA10A}">
+      <p15:sldGuideLst xmlns:p15="http://schemas.microsoft.com/office/powerpoint/2012/main">
+        <p15:guide id="1" orient="horz" pos="2160">
+          <p15:clr>
+            <a:srgbClr val="A4A3A4"/>
+          </p15:clr>
+        </p15:guide>
+        <p15:guide id="2" pos="2880">
+          <p15:clr>
+            <a:srgbClr val="A4A3A4"/>
+          </p15:clr>
+        </p15:guide>
+      </p15:sldGuideLst>
+    </p:ext>
+  </p:extLst>
 </p:presentation>
 </file>
 
@@ -145,10 +161,9 @@
           <a:lstStyle/>
           <a:p>
             <a:r>
-              <a:rPr lang="en-US" smtClean="0"/>
+              <a:rPr lang="en-US"/>
               <a:t>Click to edit Master title style</a:t>
             </a:r>
-            <a:endParaRPr lang="en-US"/>
           </a:p>
         </p:txBody>
       </p:sp>
@@ -264,10 +279,9 @@
           </a:lstStyle>
           <a:p>
             <a:r>
-              <a:rPr lang="en-US" smtClean="0"/>
+              <a:rPr lang="en-US"/>
               <a:t>Click to edit Master subtitle style</a:t>
             </a:r>
-            <a:endParaRPr lang="en-US"/>
           </a:p>
         </p:txBody>
       </p:sp>
@@ -288,7 +302,7 @@
           <a:p>
             <a:fld id="{5BCAD085-E8A6-8845-BD4E-CB4CCA059FC4}" type="datetimeFigureOut">
               <a:rPr lang="en-US" smtClean="0"/>
-              <a:t>1/27/13</a:t>
+              <a:t>6/18/2026</a:t>
             </a:fld>
             <a:endParaRPr lang="en-US"/>
           </a:p>
@@ -382,10 +396,9 @@
           <a:lstStyle/>
           <a:p>
             <a:r>
-              <a:rPr lang="en-US" smtClean="0"/>
+              <a:rPr lang="en-US"/>
               <a:t>Click to edit Master title style</a:t>
             </a:r>
-            <a:endParaRPr lang="en-US"/>
           </a:p>
         </p:txBody>
       </p:sp>
@@ -406,38 +419,37 @@
           <a:p>
             <a:pPr lvl="0"/>
             <a:r>
-              <a:rPr lang="en-US" smtClean="0"/>
+              <a:rPr lang="en-US"/>
               <a:t>Click to edit Master text styles</a:t>
             </a:r>
           </a:p>
           <a:p>
             <a:pPr lvl="1"/>
             <a:r>
-              <a:rPr lang="en-US" smtClean="0"/>
+              <a:rPr lang="en-US"/>
               <a:t>Second level</a:t>
             </a:r>
           </a:p>
           <a:p>
             <a:pPr lvl="2"/>
             <a:r>
-              <a:rPr lang="en-US" smtClean="0"/>
+              <a:rPr lang="en-US"/>
               <a:t>Third level</a:t>
             </a:r>
           </a:p>
           <a:p>
             <a:pPr lvl="3"/>
             <a:r>
-              <a:rPr lang="en-US" smtClean="0"/>
+              <a:rPr lang="en-US"/>
               <a:t>Fourth level</a:t>
             </a:r>
           </a:p>
           <a:p>
             <a:pPr lvl="4"/>
             <a:r>
-              <a:rPr lang="en-US" smtClean="0"/>
+              <a:rPr lang="en-US"/>
               <a:t>Fifth level</a:t>
             </a:r>
-            <a:endParaRPr lang="en-US"/>
           </a:p>
         </p:txBody>
       </p:sp>
@@ -458,7 +470,7 @@
           <a:p>
             <a:fld id="{5BCAD085-E8A6-8845-BD4E-CB4CCA059FC4}" type="datetimeFigureOut">
               <a:rPr lang="en-US" smtClean="0"/>
-              <a:t>1/27/13</a:t>
+              <a:t>6/18/2026</a:t>
             </a:fld>
             <a:endParaRPr lang="en-US"/>
           </a:p>
@@ -557,10 +569,9 @@
           <a:lstStyle/>
           <a:p>
             <a:r>
-              <a:rPr lang="en-US" smtClean="0"/>
+              <a:rPr lang="en-US"/>
               <a:t>Click to edit Master title style</a:t>
             </a:r>
-            <a:endParaRPr lang="en-US"/>
           </a:p>
         </p:txBody>
       </p:sp>
@@ -586,38 +597,37 @@
           <a:p>
             <a:pPr lvl="0"/>
             <a:r>
-              <a:rPr lang="en-US" smtClean="0"/>
+              <a:rPr lang="en-US"/>
               <a:t>Click to edit Master text styles</a:t>
             </a:r>
           </a:p>
           <a:p>
             <a:pPr lvl="1"/>
             <a:r>
-              <a:rPr lang="en-US" smtClean="0"/>
+              <a:rPr lang="en-US"/>
               <a:t>Second level</a:t>
             </a:r>
           </a:p>
           <a:p>
             <a:pPr lvl="2"/>
             <a:r>
-              <a:rPr lang="en-US" smtClean="0"/>
+              <a:rPr lang="en-US"/>
               <a:t>Third level</a:t>
             </a:r>
           </a:p>
           <a:p>
             <a:pPr lvl="3"/>
             <a:r>
-              <a:rPr lang="en-US" smtClean="0"/>
+              <a:rPr lang="en-US"/>
               <a:t>Fourth level</a:t>
             </a:r>
           </a:p>
           <a:p>
             <a:pPr lvl="4"/>
             <a:r>
-              <a:rPr lang="en-US" smtClean="0"/>
+              <a:rPr lang="en-US"/>
               <a:t>Fifth level</a:t>
             </a:r>
-            <a:endParaRPr lang="en-US"/>
           </a:p>
         </p:txBody>
       </p:sp>
@@ -638,7 +648,7 @@
           <a:p>
             <a:fld id="{5BCAD085-E8A6-8845-BD4E-CB4CCA059FC4}" type="datetimeFigureOut">
               <a:rPr lang="en-US" smtClean="0"/>
-              <a:t>1/27/13</a:t>
+              <a:t>6/18/2026</a:t>
             </a:fld>
             <a:endParaRPr lang="en-US"/>
           </a:p>
@@ -732,10 +742,9 @@
           <a:lstStyle/>
           <a:p>
             <a:r>
-              <a:rPr lang="en-US" smtClean="0"/>
+              <a:rPr lang="en-US"/>
               <a:t>Click to edit Master title style</a:t>
             </a:r>
-            <a:endParaRPr lang="en-US"/>
           </a:p>
         </p:txBody>
       </p:sp>
@@ -756,38 +765,37 @@
           <a:p>
             <a:pPr lvl="0"/>
             <a:r>
-              <a:rPr lang="en-US" smtClean="0"/>
+              <a:rPr lang="en-US"/>
               <a:t>Click to edit Master text styles</a:t>
             </a:r>
           </a:p>
           <a:p>
             <a:pPr lvl="1"/>
             <a:r>
-              <a:rPr lang="en-US" smtClean="0"/>
+              <a:rPr lang="en-US"/>
               <a:t>Second level</a:t>
             </a:r>
           </a:p>
           <a:p>
             <a:pPr lvl="2"/>
             <a:r>
-              <a:rPr lang="en-US" smtClean="0"/>
+              <a:rPr lang="en-US"/>
               <a:t>Third level</a:t>
             </a:r>
           </a:p>
           <a:p>
             <a:pPr lvl="3"/>
             <a:r>
-              <a:rPr lang="en-US" smtClean="0"/>
+              <a:rPr lang="en-US"/>
               <a:t>Fourth level</a:t>
             </a:r>
           </a:p>
           <a:p>
             <a:pPr lvl="4"/>
             <a:r>
-              <a:rPr lang="en-US" smtClean="0"/>
+              <a:rPr lang="en-US"/>
               <a:t>Fifth level</a:t>
             </a:r>
-            <a:endParaRPr lang="en-US"/>
           </a:p>
         </p:txBody>
       </p:sp>
@@ -808,7 +816,7 @@
           <a:p>
             <a:fld id="{5BCAD085-E8A6-8845-BD4E-CB4CCA059FC4}" type="datetimeFigureOut">
               <a:rPr lang="en-US" smtClean="0"/>
-              <a:t>1/27/13</a:t>
+              <a:t>6/18/2026</a:t>
             </a:fld>
             <a:endParaRPr lang="en-US"/>
           </a:p>
@@ -911,10 +919,9 @@
           </a:lstStyle>
           <a:p>
             <a:r>
-              <a:rPr lang="en-US" smtClean="0"/>
+              <a:rPr lang="en-US"/>
               <a:t>Click to edit Master title style</a:t>
             </a:r>
-            <a:endParaRPr lang="en-US"/>
           </a:p>
         </p:txBody>
       </p:sp>
@@ -1031,7 +1038,7 @@
           <a:p>
             <a:pPr lvl="0"/>
             <a:r>
-              <a:rPr lang="en-US" smtClean="0"/>
+              <a:rPr lang="en-US"/>
               <a:t>Click to edit Master text styles</a:t>
             </a:r>
           </a:p>
@@ -1054,7 +1061,7 @@
           <a:p>
             <a:fld id="{5BCAD085-E8A6-8845-BD4E-CB4CCA059FC4}" type="datetimeFigureOut">
               <a:rPr lang="en-US" smtClean="0"/>
-              <a:t>1/27/13</a:t>
+              <a:t>6/18/2026</a:t>
             </a:fld>
             <a:endParaRPr lang="en-US"/>
           </a:p>
@@ -1148,10 +1155,9 @@
           <a:lstStyle/>
           <a:p>
             <a:r>
-              <a:rPr lang="en-US" smtClean="0"/>
+              <a:rPr lang="en-US"/>
               <a:t>Click to edit Master title style</a:t>
             </a:r>
-            <a:endParaRPr lang="en-US"/>
           </a:p>
         </p:txBody>
       </p:sp>
@@ -1205,38 +1211,37 @@
           <a:p>
             <a:pPr lvl="0"/>
             <a:r>
-              <a:rPr lang="en-US" smtClean="0"/>
+              <a:rPr lang="en-US"/>
               <a:t>Click to edit Master text styles</a:t>
             </a:r>
           </a:p>
           <a:p>
             <a:pPr lvl="1"/>
             <a:r>
-              <a:rPr lang="en-US" smtClean="0"/>
+              <a:rPr lang="en-US"/>
               <a:t>Second level</a:t>
             </a:r>
           </a:p>
           <a:p>
             <a:pPr lvl="2"/>
             <a:r>
-              <a:rPr lang="en-US" smtClean="0"/>
+              <a:rPr lang="en-US"/>
               <a:t>Third level</a:t>
             </a:r>
           </a:p>
           <a:p>
             <a:pPr lvl="3"/>
             <a:r>
-              <a:rPr lang="en-US" smtClean="0"/>
+              <a:rPr lang="en-US"/>
               <a:t>Fourth level</a:t>
             </a:r>
           </a:p>
           <a:p>
             <a:pPr lvl="4"/>
             <a:r>
-              <a:rPr lang="en-US" smtClean="0"/>
+              <a:rPr lang="en-US"/>
               <a:t>Fifth level</a:t>
             </a:r>
-            <a:endParaRPr lang="en-US"/>
           </a:p>
         </p:txBody>
       </p:sp>
@@ -1290,38 +1295,37 @@
           <a:p>
             <a:pPr lvl="0"/>
             <a:r>
-              <a:rPr lang="en-US" smtClean="0"/>
+              <a:rPr lang="en-US"/>
               <a:t>Click to edit Master text styles</a:t>
             </a:r>
           </a:p>
           <a:p>
             <a:pPr lvl="1"/>
             <a:r>
-              <a:rPr lang="en-US" smtClean="0"/>
+              <a:rPr lang="en-US"/>
               <a:t>Second level</a:t>
             </a:r>
           </a:p>
           <a:p>
             <a:pPr lvl="2"/>
             <a:r>
-              <a:rPr lang="en-US" smtClean="0"/>
+              <a:rPr lang="en-US"/>
               <a:t>Third level</a:t>
             </a:r>
           </a:p>
           <a:p>
             <a:pPr lvl="3"/>
             <a:r>
-              <a:rPr lang="en-US" smtClean="0"/>
+              <a:rPr lang="en-US"/>
               <a:t>Fourth level</a:t>
             </a:r>
           </a:p>
           <a:p>
             <a:pPr lvl="4"/>
             <a:r>
-              <a:rPr lang="en-US" smtClean="0"/>
+              <a:rPr lang="en-US"/>
               <a:t>Fifth level</a:t>
             </a:r>
-            <a:endParaRPr lang="en-US"/>
           </a:p>
         </p:txBody>
       </p:sp>
@@ -1342,7 +1346,7 @@
           <a:p>
             <a:fld id="{5BCAD085-E8A6-8845-BD4E-CB4CCA059FC4}" type="datetimeFigureOut">
               <a:rPr lang="en-US" smtClean="0"/>
-              <a:t>1/27/13</a:t>
+              <a:t>6/18/2026</a:t>
             </a:fld>
             <a:endParaRPr lang="en-US"/>
           </a:p>
@@ -1440,10 +1444,9 @@
           </a:lstStyle>
           <a:p>
             <a:r>
-              <a:rPr lang="en-US" smtClean="0"/>
+              <a:rPr lang="en-US"/>
               <a:t>Click to edit Master title style</a:t>
             </a:r>
-            <a:endParaRPr lang="en-US"/>
           </a:p>
         </p:txBody>
       </p:sp>
@@ -1506,7 +1509,7 @@
           <a:p>
             <a:pPr lvl="0"/>
             <a:r>
-              <a:rPr lang="en-US" smtClean="0"/>
+              <a:rPr lang="en-US"/>
               <a:t>Click to edit Master text styles</a:t>
             </a:r>
           </a:p>
@@ -1562,38 +1565,37 @@
           <a:p>
             <a:pPr lvl="0"/>
             <a:r>
-              <a:rPr lang="en-US" smtClean="0"/>
+              <a:rPr lang="en-US"/>
               <a:t>Click to edit Master text styles</a:t>
             </a:r>
           </a:p>
           <a:p>
             <a:pPr lvl="1"/>
             <a:r>
-              <a:rPr lang="en-US" smtClean="0"/>
+              <a:rPr lang="en-US"/>
               <a:t>Second level</a:t>
             </a:r>
           </a:p>
           <a:p>
             <a:pPr lvl="2"/>
             <a:r>
-              <a:rPr lang="en-US" smtClean="0"/>
+              <a:rPr lang="en-US"/>
               <a:t>Third level</a:t>
             </a:r>
           </a:p>
           <a:p>
             <a:pPr lvl="3"/>
             <a:r>
-              <a:rPr lang="en-US" smtClean="0"/>
+              <a:rPr lang="en-US"/>
               <a:t>Fourth level</a:t>
             </a:r>
           </a:p>
           <a:p>
             <a:pPr lvl="4"/>
             <a:r>
-              <a:rPr lang="en-US" smtClean="0"/>
+              <a:rPr lang="en-US"/>
               <a:t>Fifth level</a:t>
             </a:r>
-            <a:endParaRPr lang="en-US"/>
           </a:p>
         </p:txBody>
       </p:sp>
@@ -1656,7 +1658,7 @@
           <a:p>
             <a:pPr lvl="0"/>
             <a:r>
-              <a:rPr lang="en-US" smtClean="0"/>
+              <a:rPr lang="en-US"/>
               <a:t>Click to edit Master text styles</a:t>
             </a:r>
           </a:p>
@@ -1712,38 +1714,37 @@
           <a:p>
             <a:pPr lvl="0"/>
             <a:r>
-              <a:rPr lang="en-US" smtClean="0"/>
+              <a:rPr lang="en-US"/>
               <a:t>Click to edit Master text styles</a:t>
             </a:r>
           </a:p>
           <a:p>
             <a:pPr lvl="1"/>
             <a:r>
-              <a:rPr lang="en-US" smtClean="0"/>
+              <a:rPr lang="en-US"/>
               <a:t>Second level</a:t>
             </a:r>
           </a:p>
           <a:p>
             <a:pPr lvl="2"/>
             <a:r>
-              <a:rPr lang="en-US" smtClean="0"/>
+              <a:rPr lang="en-US"/>
               <a:t>Third level</a:t>
             </a:r>
           </a:p>
           <a:p>
             <a:pPr lvl="3"/>
             <a:r>
-              <a:rPr lang="en-US" smtClean="0"/>
+              <a:rPr lang="en-US"/>
               <a:t>Fourth level</a:t>
             </a:r>
           </a:p>
           <a:p>
             <a:pPr lvl="4"/>
             <a:r>
-              <a:rPr lang="en-US" smtClean="0"/>
+              <a:rPr lang="en-US"/>
               <a:t>Fifth level</a:t>
             </a:r>
-            <a:endParaRPr lang="en-US"/>
           </a:p>
         </p:txBody>
       </p:sp>
@@ -1764,7 +1765,7 @@
           <a:p>
             <a:fld id="{5BCAD085-E8A6-8845-BD4E-CB4CCA059FC4}" type="datetimeFigureOut">
               <a:rPr lang="en-US" smtClean="0"/>
-              <a:t>1/27/13</a:t>
+              <a:t>6/18/2026</a:t>
             </a:fld>
             <a:endParaRPr lang="en-US"/>
           </a:p>
@@ -1858,10 +1859,9 @@
           <a:lstStyle/>
           <a:p>
             <a:r>
-              <a:rPr lang="en-US" smtClean="0"/>
+              <a:rPr lang="en-US"/>
               <a:t>Click to edit Master title style</a:t>
             </a:r>
-            <a:endParaRPr lang="en-US"/>
           </a:p>
         </p:txBody>
       </p:sp>
@@ -1882,7 +1882,7 @@
           <a:p>
             <a:fld id="{5BCAD085-E8A6-8845-BD4E-CB4CCA059FC4}" type="datetimeFigureOut">
               <a:rPr lang="en-US" smtClean="0"/>
-              <a:t>1/27/13</a:t>
+              <a:t>6/18/2026</a:t>
             </a:fld>
             <a:endParaRPr lang="en-US"/>
           </a:p>
@@ -1977,7 +1977,7 @@
           <a:p>
             <a:fld id="{5BCAD085-E8A6-8845-BD4E-CB4CCA059FC4}" type="datetimeFigureOut">
               <a:rPr lang="en-US" smtClean="0"/>
-              <a:t>1/27/13</a:t>
+              <a:t>6/18/2026</a:t>
             </a:fld>
             <a:endParaRPr lang="en-US"/>
           </a:p>
@@ -2080,10 +2080,9 @@
           </a:lstStyle>
           <a:p>
             <a:r>
-              <a:rPr lang="en-US" smtClean="0"/>
+              <a:rPr lang="en-US"/>
               <a:t>Click to edit Master title style</a:t>
             </a:r>
-            <a:endParaRPr lang="en-US"/>
           </a:p>
         </p:txBody>
       </p:sp>
@@ -2137,38 +2136,37 @@
           <a:p>
             <a:pPr lvl="0"/>
             <a:r>
-              <a:rPr lang="en-US" smtClean="0"/>
+              <a:rPr lang="en-US"/>
               <a:t>Click to edit Master text styles</a:t>
             </a:r>
           </a:p>
           <a:p>
             <a:pPr lvl="1"/>
             <a:r>
-              <a:rPr lang="en-US" smtClean="0"/>
+              <a:rPr lang="en-US"/>
               <a:t>Second level</a:t>
             </a:r>
           </a:p>
           <a:p>
             <a:pPr lvl="2"/>
             <a:r>
-              <a:rPr lang="en-US" smtClean="0"/>
+              <a:rPr lang="en-US"/>
               <a:t>Third level</a:t>
             </a:r>
           </a:p>
           <a:p>
             <a:pPr lvl="3"/>
             <a:r>
-              <a:rPr lang="en-US" smtClean="0"/>
+              <a:rPr lang="en-US"/>
               <a:t>Fourth level</a:t>
             </a:r>
           </a:p>
           <a:p>
             <a:pPr lvl="4"/>
             <a:r>
-              <a:rPr lang="en-US" smtClean="0"/>
+              <a:rPr lang="en-US"/>
               <a:t>Fifth level</a:t>
             </a:r>
-            <a:endParaRPr lang="en-US"/>
           </a:p>
         </p:txBody>
       </p:sp>
@@ -2231,7 +2229,7 @@
           <a:p>
             <a:pPr lvl="0"/>
             <a:r>
-              <a:rPr lang="en-US" smtClean="0"/>
+              <a:rPr lang="en-US"/>
               <a:t>Click to edit Master text styles</a:t>
             </a:r>
           </a:p>
@@ -2254,7 +2252,7 @@
           <a:p>
             <a:fld id="{5BCAD085-E8A6-8845-BD4E-CB4CCA059FC4}" type="datetimeFigureOut">
               <a:rPr lang="en-US" smtClean="0"/>
-              <a:t>1/27/13</a:t>
+              <a:t>6/18/2026</a:t>
             </a:fld>
             <a:endParaRPr lang="en-US"/>
           </a:p>
@@ -2357,10 +2355,9 @@
           </a:lstStyle>
           <a:p>
             <a:r>
-              <a:rPr lang="en-US" smtClean="0"/>
+              <a:rPr lang="en-US"/>
               <a:t>Click to edit Master title style</a:t>
             </a:r>
-            <a:endParaRPr lang="en-US"/>
           </a:p>
         </p:txBody>
       </p:sp>
@@ -2484,7 +2481,7 @@
           <a:p>
             <a:pPr lvl="0"/>
             <a:r>
-              <a:rPr lang="en-US" smtClean="0"/>
+              <a:rPr lang="en-US"/>
               <a:t>Click to edit Master text styles</a:t>
             </a:r>
           </a:p>
@@ -2507,7 +2504,7 @@
           <a:p>
             <a:fld id="{5BCAD085-E8A6-8845-BD4E-CB4CCA059FC4}" type="datetimeFigureOut">
               <a:rPr lang="en-US" smtClean="0"/>
-              <a:t>1/27/13</a:t>
+              <a:t>6/18/2026</a:t>
             </a:fld>
             <a:endParaRPr lang="en-US"/>
           </a:p>
@@ -2616,10 +2613,9 @@
           <a:lstStyle/>
           <a:p>
             <a:r>
-              <a:rPr lang="en-US" smtClean="0"/>
+              <a:rPr lang="en-US"/>
               <a:t>Click to edit Master title style</a:t>
             </a:r>
-            <a:endParaRPr lang="en-US"/>
           </a:p>
         </p:txBody>
       </p:sp>
@@ -2650,38 +2646,37 @@
           <a:p>
             <a:pPr lvl="0"/>
             <a:r>
-              <a:rPr lang="en-US" smtClean="0"/>
+              <a:rPr lang="en-US"/>
               <a:t>Click to edit Master text styles</a:t>
             </a:r>
           </a:p>
           <a:p>
             <a:pPr lvl="1"/>
             <a:r>
-              <a:rPr lang="en-US" smtClean="0"/>
+              <a:rPr lang="en-US"/>
               <a:t>Second level</a:t>
             </a:r>
           </a:p>
           <a:p>
             <a:pPr lvl="2"/>
             <a:r>
-              <a:rPr lang="en-US" smtClean="0"/>
+              <a:rPr lang="en-US"/>
               <a:t>Third level</a:t>
             </a:r>
           </a:p>
           <a:p>
             <a:pPr lvl="3"/>
             <a:r>
-              <a:rPr lang="en-US" smtClean="0"/>
+              <a:rPr lang="en-US"/>
               <a:t>Fourth level</a:t>
             </a:r>
           </a:p>
           <a:p>
             <a:pPr lvl="4"/>
             <a:r>
-              <a:rPr lang="en-US" smtClean="0"/>
+              <a:rPr lang="en-US"/>
               <a:t>Fifth level</a:t>
             </a:r>
-            <a:endParaRPr lang="en-US"/>
           </a:p>
         </p:txBody>
       </p:sp>
@@ -2720,7 +2715,7 @@
           <a:p>
             <a:fld id="{5BCAD085-E8A6-8845-BD4E-CB4CCA059FC4}" type="datetimeFigureOut">
               <a:rPr lang="en-US" smtClean="0"/>
-              <a:t>1/27/13</a:t>
+              <a:t>6/18/2026</a:t>
             </a:fld>
             <a:endParaRPr lang="en-US"/>
           </a:p>
@@ -3079,7 +3074,7 @@
 </file>
 
 <file path=ppt/slides/slide1.xml><?xml version="1.0" encoding="utf-8"?>
-<p:sld xmlns:a="http://schemas.openxmlformats.org/drawingml/2006/main" xmlns:p="http://schemas.openxmlformats.org/presentationml/2006/main" xmlns:r="http://schemas.openxmlformats.org/officeDocument/2006/relationships">
+<p:sld xmlns:a="http://schemas.openxmlformats.org/drawingml/2006/main" xmlns:r="http://schemas.openxmlformats.org/officeDocument/2006/relationships" xmlns:p="http://schemas.openxmlformats.org/presentationml/2006/main">
   <p:cSld>
     <p:spTree>
       <p:nvGrpSpPr>
@@ -3087,7 +3082,14 @@
         <p:cNvGrpSpPr/>
         <p:nvPr/>
       </p:nvGrpSpPr>
-      <p:grpSpPr/>
+      <p:grpSpPr>
+        <a:xfrm>
+          <a:off x="0" y="0"/>
+          <a:ext cx="0" cy="0"/>
+          <a:chOff x="0" y="0"/>
+          <a:chExt cx="0" cy="0"/>
+        </a:xfrm>
+      </p:grpSpPr>
       <p:sp>
         <p:nvSpPr>
           <p:cNvPr id="2" name="Rectangle 1"/>
@@ -3096,8 +3098,8 @@
         </p:nvSpPr>
         <p:spPr>
           <a:xfrm>
-            <a:off x="384048" y="274320"/>
-            <a:ext cx="11420856" cy="566928"/>
+            <a:off x="384048" y="219456"/>
+            <a:ext cx="11420856" cy="475488"/>
           </a:xfrm>
           <a:prstGeom prst="rect">
             <a:avLst/>
@@ -3123,7 +3125,7 @@
           </a:fontRef>
         </p:style>
         <p:txBody>
-          <a:bodyPr rtlCol="0" anchor="t" wrap="square" lIns="109728" rIns="109728" tIns="54864" bIns="36576"/>
+          <a:bodyPr wrap="square" lIns="109728" rIns="109728" bIns="36576" rtlCol="0" anchor="t"/>
           <a:lstStyle/>
           <a:p>
             <a:pPr algn="l">
@@ -3135,13 +3137,22 @@
               </a:spcAft>
             </a:pPr>
             <a:r>
-              <a:rPr sz="2600" b="1" i="0">
+              <a:rPr sz="2400" b="1" i="0" dirty="0" err="1">
                 <a:solidFill>
                   <a:srgbClr val="000000"/>
                 </a:solidFill>
                 <a:latin typeface="Segoe UI"/>
               </a:rPr>
-              <a:t>NeuroSync — Slide 1 (Submission Summary)</a:t>
+              <a:t>NeuroSync</a:t>
+            </a:r>
+            <a:r>
+              <a:rPr sz="2400" b="1" i="0" dirty="0">
+                <a:solidFill>
+                  <a:srgbClr val="000000"/>
+                </a:solidFill>
+                <a:latin typeface="Segoe UI"/>
+              </a:rPr>
+              <a:t> (Submission Summary)</a:t>
             </a:r>
           </a:p>
         </p:txBody>
@@ -3154,8 +3165,8 @@
         </p:nvSpPr>
         <p:spPr>
           <a:xfrm>
-            <a:off x="310896" y="868680"/>
-            <a:ext cx="11420856" cy="932688"/>
+            <a:off x="310896" y="731520"/>
+            <a:ext cx="11420856" cy="896112"/>
           </a:xfrm>
           <a:prstGeom prst="rect">
             <a:avLst/>
@@ -3183,7 +3194,7 @@
           </a:fontRef>
         </p:style>
         <p:txBody>
-          <a:bodyPr rtlCol="0" anchor="t" wrap="square" lIns="109728" rIns="109728" tIns="54864" bIns="36576"/>
+          <a:bodyPr wrap="square" lIns="109728" rIns="109728" bIns="36576" rtlCol="0" anchor="t"/>
           <a:lstStyle/>
           <a:p>
             <a:pPr algn="ctr">
@@ -3195,7 +3206,7 @@
               </a:spcAft>
             </a:pPr>
             <a:r>
-              <a:rPr sz="1300" b="1" i="0">
+              <a:rPr sz="1300" b="1" i="0" dirty="0">
                 <a:solidFill>
                   <a:srgbClr val="FFFFFF"/>
                 </a:solidFill>
@@ -3214,13 +3225,13 @@
               </a:spcAft>
             </a:pPr>
             <a:r>
-              <a:rPr sz="950" b="0" i="0">
+              <a:rPr sz="950" b="0" i="0" dirty="0">
                 <a:solidFill>
                   <a:srgbClr val="FFFFFF"/>
                 </a:solidFill>
                 <a:latin typeface="Segoe UI"/>
               </a:rPr>
-              <a:t>Employees with ADHD and dyslexia spend far more energy turning everyday workplace text — emails, chats, tickets — into started, finished work. Tasks, deadlines and priorities hide inside long messages, creating a hidden “cognitive tax” that drives missed priorities, cognitive overload and burnout — not from lack of ability, but because mainstream tools assume one way of processing information.</a:t>
+              <a:t>People with ADHD and dyslexia have to work much harder to turn everyday work messages — long emails, chats and tickets — into finished work. Tasks and deadlines stay hidden inside long text. That extra mental effort is a hidden “cognitive tax” that leads to missed priorities, overload and burnout. The problem isn’t their ability — it’s that most work tools are built for only one way of thinking.</a:t>
             </a:r>
           </a:p>
         </p:txBody>
@@ -3233,8 +3244,8 @@
         </p:nvSpPr>
         <p:spPr>
           <a:xfrm>
-            <a:off x="310896" y="1847088"/>
-            <a:ext cx="11420856" cy="475488"/>
+            <a:off x="310896" y="1664208"/>
+            <a:ext cx="11420856" cy="804672"/>
           </a:xfrm>
           <a:prstGeom prst="rect">
             <a:avLst/>
@@ -3262,12 +3273,16 @@
           </a:fontRef>
         </p:style>
         <p:txBody>
-          <a:bodyPr rtlCol="0" anchor="t" wrap="square" lIns="109728" rIns="109728" tIns="54864" bIns="36576"/>
-          <a:lstStyle/>
-          <a:p>
-            <a:pPr algn="l"/>
-            <a:r>
-              <a:rPr sz="1100" b="1" i="1">
+          <a:bodyPr wrap="square" lIns="109728" rIns="109728" bIns="36576" rtlCol="0" anchor="t"/>
+          <a:lstStyle/>
+          <a:p>
+            <a:pPr>
+              <a:spcAft>
+                <a:spcPts val="200"/>
+              </a:spcAft>
+            </a:pPr>
+            <a:r>
+              <a:rPr sz="1050" b="1" u="none" dirty="0">
                 <a:solidFill>
                   <a:srgbClr val="FFFFFF"/>
                 </a:solidFill>
@@ -3276,14 +3291,154 @@
               <a:t>Who is this solution Servicing:  </a:t>
             </a:r>
             <a:r>
-              <a:rPr sz="1000" b="0" i="1">
+              <a:rPr sz="950" b="0" u="none" dirty="0">
                 <a:solidFill>
                   <a:srgbClr val="FFFFFF"/>
                 </a:solidFill>
-                <a:latin typeface="Segoe UI"/>
-              </a:rPr>
-              <a:t>Accenture knowledge-workers who are neurodivergent — primarily ADHD and dyslexia (they co-occur in ~1 in 2 people; 15–20% of people are neurodivergent). Champions/buyers: Inclusion &amp; Diversity and HR.</a:t>
-            </a:r>
+                <a:latin typeface="Segoe UI" panose="020B0502040204020203" pitchFamily="34" charset="0"/>
+                <a:cs typeface="Segoe UI" panose="020B0502040204020203" pitchFamily="34" charset="0"/>
+              </a:rPr>
+              <a:t>Accenture employees who are neurodivergent. </a:t>
+            </a:r>
+            <a:r>
+              <a:rPr lang="en-US" sz="950" dirty="0">
+                <a:solidFill>
+                  <a:srgbClr val="FFFFFF"/>
+                </a:solidFill>
+                <a:latin typeface="Segoe UI" panose="020B0502040204020203" pitchFamily="34" charset="0"/>
+                <a:cs typeface="Segoe UI" panose="020B0502040204020203" pitchFamily="34" charset="0"/>
+              </a:rPr>
+              <a:t>— primarily ADHD and dyslexia (they co-occur in ~1 in 2 people </a:t>
+            </a:r>
+            <a:r>
+              <a:rPr lang="en-US" sz="950" dirty="0">
+                <a:solidFill>
+                  <a:schemeClr val="bg1"/>
+                </a:solidFill>
+                <a:latin typeface="Segoe UI" panose="020B0502040204020203" pitchFamily="34" charset="0"/>
+                <a:cs typeface="Segoe UI" panose="020B0502040204020203" pitchFamily="34" charset="0"/>
+              </a:rPr>
+              <a:t>(</a:t>
+            </a:r>
+            <a:r>
+              <a:rPr lang="en-US" sz="950" b="1" dirty="0">
+                <a:solidFill>
+                  <a:schemeClr val="bg1"/>
+                </a:solidFill>
+                <a:latin typeface="Segoe UI" panose="020B0502040204020203" pitchFamily="34" charset="0"/>
+                <a:cs typeface="Segoe UI" panose="020B0502040204020203" pitchFamily="34" charset="0"/>
+                <a:hlinkClick r:id="rId2">
+                  <a:extLst>
+                    <a:ext uri="{A12FA001-AC4F-418D-AE19-62706E023703}">
+                      <ahyp:hlinkClr xmlns:ahyp="http://schemas.microsoft.com/office/drawing/2018/hyperlinkcolor" val="tx"/>
+                    </a:ext>
+                  </a:extLst>
+                </a:hlinkClick>
+              </a:rPr>
+              <a:t>Source</a:t>
+            </a:r>
+            <a:r>
+              <a:rPr lang="en-US" sz="950" dirty="0">
+                <a:solidFill>
+                  <a:srgbClr val="FFFFFF"/>
+                </a:solidFill>
+                <a:latin typeface="Segoe UI" panose="020B0502040204020203" pitchFamily="34" charset="0"/>
+                <a:cs typeface="Segoe UI" panose="020B0502040204020203" pitchFamily="34" charset="0"/>
+              </a:rPr>
+              <a:t>); 10–15% of people are neurodivergent (</a:t>
+            </a:r>
+            <a:r>
+              <a:rPr lang="en-US" sz="950" b="1" dirty="0">
+                <a:solidFill>
+                  <a:schemeClr val="bg1"/>
+                </a:solidFill>
+                <a:latin typeface="Segoe UI" panose="020B0502040204020203" pitchFamily="34" charset="0"/>
+                <a:cs typeface="Segoe UI" panose="020B0502040204020203" pitchFamily="34" charset="0"/>
+                <a:hlinkClick r:id="rId3">
+                  <a:extLst>
+                    <a:ext uri="{A12FA001-AC4F-418D-AE19-62706E023703}">
+                      <ahyp:hlinkClr xmlns:ahyp="http://schemas.microsoft.com/office/drawing/2018/hyperlinkcolor" val="tx"/>
+                    </a:ext>
+                  </a:extLst>
+                </a:hlinkClick>
+              </a:rPr>
+              <a:t>ADHD</a:t>
+            </a:r>
+            <a:r>
+              <a:rPr lang="en-US" sz="950" dirty="0">
+                <a:solidFill>
+                  <a:srgbClr val="FFFFFF"/>
+                </a:solidFill>
+                <a:latin typeface="Segoe UI" panose="020B0502040204020203" pitchFamily="34" charset="0"/>
+                <a:cs typeface="Segoe UI" panose="020B0502040204020203" pitchFamily="34" charset="0"/>
+              </a:rPr>
+              <a:t>/ </a:t>
+            </a:r>
+            <a:r>
+              <a:rPr lang="en-US" sz="950" b="1" dirty="0">
+                <a:solidFill>
+                  <a:schemeClr val="bg1"/>
+                </a:solidFill>
+                <a:latin typeface="Segoe UI" panose="020B0502040204020203" pitchFamily="34" charset="0"/>
+                <a:cs typeface="Segoe UI" panose="020B0502040204020203" pitchFamily="34" charset="0"/>
+                <a:hlinkClick r:id="rId4">
+                  <a:extLst>
+                    <a:ext uri="{A12FA001-AC4F-418D-AE19-62706E023703}">
+                      <ahyp:hlinkClr xmlns:ahyp="http://schemas.microsoft.com/office/drawing/2018/hyperlinkcolor" val="tx"/>
+                    </a:ext>
+                  </a:extLst>
+                </a:hlinkClick>
+              </a:rPr>
+              <a:t>Dyslexia</a:t>
+            </a:r>
+            <a:r>
+              <a:rPr lang="en-US" sz="950" b="1" dirty="0">
+                <a:solidFill>
+                  <a:schemeClr val="bg1"/>
+                </a:solidFill>
+                <a:latin typeface="Segoe UI" panose="020B0502040204020203" pitchFamily="34" charset="0"/>
+                <a:cs typeface="Segoe UI" panose="020B0502040204020203" pitchFamily="34" charset="0"/>
+              </a:rPr>
+              <a:t> </a:t>
+            </a:r>
+            <a:r>
+              <a:rPr lang="en-US" sz="950" dirty="0">
+                <a:solidFill>
+                  <a:srgbClr val="FFFFFF"/>
+                </a:solidFill>
+                <a:latin typeface="Segoe UI" panose="020B0502040204020203" pitchFamily="34" charset="0"/>
+                <a:cs typeface="Segoe UI" panose="020B0502040204020203" pitchFamily="34" charset="0"/>
+              </a:rPr>
+              <a:t>)).</a:t>
+            </a:r>
+            <a:r>
+              <a:rPr sz="950" b="0" u="none" dirty="0">
+                <a:solidFill>
+                  <a:srgbClr val="FFFFFF"/>
+                </a:solidFill>
+                <a:latin typeface="Segoe UI" panose="020B0502040204020203" pitchFamily="34" charset="0"/>
+                <a:cs typeface="Segoe UI" panose="020B0502040204020203" pitchFamily="34" charset="0"/>
+              </a:rPr>
+              <a:t> </a:t>
+            </a:r>
+            <a:r>
+              <a:rPr lang="en-US" sz="950" b="0" dirty="0">
+                <a:solidFill>
+                  <a:srgbClr val="E2E1DA"/>
+                </a:solidFill>
+                <a:effectLst/>
+                <a:latin typeface="Segoe UI" panose="020B0502040204020203" pitchFamily="34" charset="0"/>
+                <a:cs typeface="Segoe UI" panose="020B0502040204020203" pitchFamily="34" charset="0"/>
+              </a:rPr>
+              <a:t>HR and the Inclusion &amp; Diversity (I&amp;D) team, who own employee wellbeing and inclusion.</a:t>
+            </a:r>
+            <a:endParaRPr sz="950" b="0" u="none" dirty="0">
+              <a:solidFill>
+                <a:srgbClr val="FFFFFF"/>
+              </a:solidFill>
+              <a:latin typeface="Segoe UI" panose="020B0502040204020203" pitchFamily="34" charset="0"/>
+              <a:cs typeface="Segoe UI" panose="020B0502040204020203" pitchFamily="34" charset="0"/>
+            </a:endParaRPr>
           </a:p>
         </p:txBody>
       </p:sp>
@@ -3295,8 +3450,8 @@
         </p:nvSpPr>
         <p:spPr>
           <a:xfrm>
-            <a:off x="320040" y="2377440"/>
-            <a:ext cx="11411712" cy="960120"/>
+            <a:off x="320040" y="2505456"/>
+            <a:ext cx="11411712" cy="1170432"/>
           </a:xfrm>
           <a:prstGeom prst="rect">
             <a:avLst/>
@@ -3326,12 +3481,19 @@
           </a:fontRef>
         </p:style>
         <p:txBody>
-          <a:bodyPr rtlCol="0" anchor="t" wrap="square" lIns="109728" rIns="109728" tIns="54864" bIns="36576"/>
-          <a:lstStyle/>
-          <a:p>
-            <a:pPr algn="l"/>
-            <a:r>
-              <a:rPr sz="1050" b="1" i="0">
+          <a:bodyPr wrap="square" lIns="109728" rIns="109728" bIns="36576" rtlCol="0" anchor="t"/>
+          <a:lstStyle/>
+          <a:p>
+            <a:pPr algn="l">
+              <a:spcBef>
+                <a:spcPts val="0"/>
+              </a:spcBef>
+              <a:spcAft>
+                <a:spcPts val="200"/>
+              </a:spcAft>
+            </a:pPr>
+            <a:r>
+              <a:rPr sz="1050" b="1" i="0" u="none" dirty="0">
                 <a:solidFill>
                   <a:srgbClr val="460073"/>
                 </a:solidFill>
@@ -3339,14 +3501,75 @@
               </a:rPr>
               <a:t>Solution Description and How it helps:  </a:t>
             </a:r>
-            <a:r>
-              <a:rPr sz="1000" b="0" i="0">
+            <a:endParaRPr lang="en-US" sz="1050" b="1" i="0" u="none" dirty="0">
+              <a:solidFill>
+                <a:srgbClr val="460073"/>
+              </a:solidFill>
+              <a:latin typeface="Segoe UI"/>
+            </a:endParaRPr>
+          </a:p>
+          <a:p>
+            <a:pPr algn="l">
+              <a:spcBef>
+                <a:spcPts val="0"/>
+              </a:spcBef>
+              <a:spcAft>
+                <a:spcPts val="200"/>
+              </a:spcAft>
+            </a:pPr>
+            <a:r>
+              <a:rPr sz="950" b="0" i="0" u="none" dirty="0" err="1">
                 <a:solidFill>
                   <a:srgbClr val="460073"/>
                 </a:solidFill>
                 <a:latin typeface="Segoe UI"/>
               </a:rPr>
-              <a:t>NeuroSync is an inclusive work companion that turns workplace communication into clarity and momentum — adapted to each person’s brain. A one-time profile makes the SAME email render as time-boxed micro-steps (ADHD) or short, plain, dyslexia-friendly text. It closes the gap from understanding AND doing: summarise → break into steps → prioritise → focus timer → execute. “Built for your brain” — not one generic chatbot answer for everyone.</a:t>
+              <a:t>NeuroSync</a:t>
+            </a:r>
+            <a:r>
+              <a:rPr sz="950" b="0" i="0" u="none" dirty="0">
+                <a:solidFill>
+                  <a:srgbClr val="460073"/>
+                </a:solidFill>
+                <a:latin typeface="Segoe UI"/>
+              </a:rPr>
+              <a:t> is an inclusive work companion that turns any work input — a long email, a document, an Outlook message, or a big task you type in — into clear, doable steps adapted to how your brain works. You set a short profile once; after that the SAME content is shown your way (ADHD → short, time-boxed micro-steps with a focus timer; dyslexia → short, plain, bulleted, dyslexia-friendly text). It closes the gap from understanding AND doing: it </a:t>
+            </a:r>
+            <a:r>
+              <a:rPr sz="950" b="0" i="0" u="none" dirty="0" err="1">
+                <a:solidFill>
+                  <a:srgbClr val="460073"/>
+                </a:solidFill>
+                <a:latin typeface="Segoe UI"/>
+              </a:rPr>
+              <a:t>summarises</a:t>
+            </a:r>
+            <a:r>
+              <a:rPr sz="950" b="0" i="0" u="none" dirty="0">
+                <a:solidFill>
+                  <a:srgbClr val="460073"/>
+                </a:solidFill>
+                <a:latin typeface="Segoe UI"/>
+              </a:rPr>
+              <a:t> the message, pulls out the real action items and hidden deadlines, breaks them into small steps, helps you </a:t>
+            </a:r>
+            <a:r>
+              <a:rPr sz="950" b="0" i="0" u="none" dirty="0" err="1">
+                <a:solidFill>
+                  <a:srgbClr val="460073"/>
+                </a:solidFill>
+                <a:latin typeface="Segoe UI"/>
+              </a:rPr>
+              <a:t>prioritise</a:t>
+            </a:r>
+            <a:r>
+              <a:rPr sz="950" b="0" i="0" u="none" dirty="0">
+                <a:solidFill>
+                  <a:srgbClr val="460073"/>
+                </a:solidFill>
+                <a:latin typeface="Segoe UI"/>
+              </a:rPr>
+              <a:t> what to do first, runs a one-step-at-a-time focus timer, and tracks progress as you finish — built for your brain, not one generic answer for everyone.</a:t>
             </a:r>
           </a:p>
         </p:txBody>
@@ -3359,8 +3582,8 @@
         </p:nvSpPr>
         <p:spPr>
           <a:xfrm>
-            <a:off x="329184" y="3383280"/>
-            <a:ext cx="11411712" cy="896112"/>
+            <a:off x="329184" y="3675888"/>
+            <a:ext cx="11411712" cy="841248"/>
           </a:xfrm>
           <a:prstGeom prst="rect">
             <a:avLst/>
@@ -3390,7 +3613,7 @@
           </a:fontRef>
         </p:style>
         <p:txBody>
-          <a:bodyPr rtlCol="0" anchor="t" wrap="square" lIns="109728" rIns="109728" tIns="54864" bIns="36576"/>
+          <a:bodyPr wrap="square" lIns="109728" rIns="109728" bIns="36576" rtlCol="0" anchor="t"/>
           <a:lstStyle/>
           <a:p>
             <a:pPr algn="l">
@@ -3398,11 +3621,11 @@
                 <a:spcPts val="0"/>
               </a:spcBef>
               <a:spcAft>
-                <a:spcPts val="100"/>
+                <a:spcPts val="200"/>
               </a:spcAft>
             </a:pPr>
             <a:r>
-              <a:rPr sz="1050" b="1" i="0">
+              <a:rPr sz="1050" b="1" i="0" dirty="0">
                 <a:solidFill>
                   <a:srgbClr val="460073"/>
                 </a:solidFill>
@@ -3417,17 +3640,26 @@
                 <a:spcPts val="0"/>
               </a:spcBef>
               <a:spcAft>
-                <a:spcPts val="100"/>
+                <a:spcPts val="200"/>
               </a:spcAft>
             </a:pPr>
             <a:r>
-              <a:rPr sz="950" b="0" i="0">
+              <a:rPr sz="1100" b="1" i="0" u="none" dirty="0">
+                <a:solidFill>
+                  <a:srgbClr val="16834A"/>
+                </a:solidFill>
+                <a:latin typeface="Segoe UI"/>
+              </a:rPr>
+              <a:t>↑  </a:t>
+            </a:r>
+            <a:r>
+              <a:rPr sz="950" b="0" i="0" u="none" dirty="0">
                 <a:solidFill>
                   <a:srgbClr val="460073"/>
                 </a:solidFill>
                 <a:latin typeface="Segoe UI"/>
               </a:rPr>
-              <a:t>•  Faster task initiation; fewer missed deadlines and priorities (less re-reading, less overwhelm)</a:t>
+              <a:t>Faster task initiation · better focus &amp; follow-through · higher engagement and retention of neurodivergent talent</a:t>
             </a:r>
           </a:p>
           <a:p>
@@ -3436,17 +3668,26 @@
                 <a:spcPts val="0"/>
               </a:spcBef>
               <a:spcAft>
-                <a:spcPts val="100"/>
+                <a:spcPts val="200"/>
               </a:spcAft>
             </a:pPr>
             <a:r>
-              <a:rPr sz="950" b="0" i="0">
+              <a:rPr sz="1100" b="1" i="0" u="none" dirty="0">
+                <a:solidFill>
+                  <a:srgbClr val="C0392B"/>
+                </a:solidFill>
+                <a:latin typeface="Segoe UI"/>
+              </a:rPr>
+              <a:t>↓  </a:t>
+            </a:r>
+            <a:r>
+              <a:rPr sz="950" b="0" i="0" u="none" dirty="0">
                 <a:solidFill>
                   <a:srgbClr val="460073"/>
                 </a:solidFill>
                 <a:latin typeface="Segoe UI"/>
               </a:rPr>
-              <a:t>•  Lower burnout, absence and ‘masking’; better engagement and retention of neurodivergent talent</a:t>
+              <a:t>Less burnout, absence and “masking” · fewer missed deadlines and priorities · less re-reading and overload</a:t>
             </a:r>
           </a:p>
           <a:p>
@@ -3455,36 +3696,36 @@
                 <a:spcPts val="0"/>
               </a:spcBef>
               <a:spcAft>
-                <a:spcPts val="100"/>
+                <a:spcPts val="200"/>
               </a:spcAft>
             </a:pPr>
             <a:r>
-              <a:rPr sz="950" b="0" i="0">
+              <a:rPr sz="950" b="1" i="0" u="none" dirty="0">
                 <a:solidFill>
                   <a:srgbClr val="460073"/>
                 </a:solidFill>
                 <a:latin typeface="Segoe UI"/>
               </a:rPr>
-              <a:t>•  Metrics: time-to-first-action, on-time completion, self-reported overwhelm, pilot adoption &amp; retention</a:t>
-            </a:r>
-          </a:p>
-          <a:p>
-            <a:pPr algn="l">
-              <a:spcBef>
-                <a:spcPts val="0"/>
-              </a:spcBef>
-              <a:spcAft>
-                <a:spcPts val="100"/>
-              </a:spcAft>
-            </a:pPr>
-            <a:r>
-              <a:rPr sz="950" b="0" i="0">
+              <a:t>Business case </a:t>
+            </a:r>
+            <a:r>
+              <a:rPr sz="950" b="1" i="0" u="none" dirty="0">
+                <a:solidFill>
+                  <a:srgbClr val="1D4ED8"/>
+                </a:solidFill>
+                <a:latin typeface="Segoe UI"/>
+                <a:hlinkClick r:id="rId5"/>
+              </a:rPr>
+              <a:t>(Accenture, 2023)</a:t>
+            </a:r>
+            <a:r>
+              <a:rPr sz="950" b="0" i="0" u="none" dirty="0">
                 <a:solidFill>
                   <a:srgbClr val="460073"/>
                 </a:solidFill>
                 <a:latin typeface="Segoe UI"/>
               </a:rPr>
-              <a:t>•  Business case: Accenture research links disability-inclusion leadership to higher revenue &amp; profitability (see appendix)</a:t>
+              <a:t>: companies leading in disability inclusion saw 1.6× revenue, 2.6× net income and 2× economic profit vs. peers.</a:t>
             </a:r>
           </a:p>
         </p:txBody>
@@ -3497,8 +3738,8 @@
         </p:nvCxnSpPr>
         <p:spPr>
           <a:xfrm>
-            <a:off x="3685032" y="4416552"/>
-            <a:ext cx="0" cy="2167128"/>
+            <a:off x="3685032" y="4590288"/>
+            <a:ext cx="0" cy="2139696"/>
           </a:xfrm>
           <a:prstGeom prst="line">
             <a:avLst/>
@@ -3532,8 +3773,8 @@
         </p:nvCxnSpPr>
         <p:spPr>
           <a:xfrm>
-            <a:off x="8147304" y="4416552"/>
-            <a:ext cx="0" cy="2167128"/>
+            <a:off x="8147304" y="4590288"/>
+            <a:ext cx="0" cy="2139696"/>
           </a:xfrm>
           <a:prstGeom prst="line">
             <a:avLst/>
@@ -3567,8 +3808,8 @@
         </p:nvSpPr>
         <p:spPr>
           <a:xfrm>
-            <a:off x="329184" y="4343400"/>
-            <a:ext cx="2889504" cy="2331720"/>
+            <a:off x="329184" y="4626864"/>
+            <a:ext cx="2889504" cy="2139696"/>
           </a:xfrm>
           <a:prstGeom prst="rect">
             <a:avLst/>
@@ -3596,7 +3837,7 @@
           </a:fontRef>
         </p:style>
         <p:txBody>
-          <a:bodyPr rtlCol="0" anchor="t" wrap="square" lIns="109728" rIns="109728" tIns="54864" bIns="36576"/>
+          <a:bodyPr wrap="square" lIns="109728" rIns="109728" bIns="36576" rtlCol="0" anchor="t"/>
           <a:lstStyle/>
           <a:p>
             <a:pPr algn="l">
@@ -3608,7 +3849,7 @@
               </a:spcAft>
             </a:pPr>
             <a:r>
-              <a:rPr sz="1100" b="1" i="0">
+              <a:rPr sz="1100" b="1" i="0" dirty="0">
                 <a:solidFill>
                   <a:srgbClr val="000000"/>
                 </a:solidFill>
@@ -3627,13 +3868,13 @@
               </a:spcAft>
             </a:pPr>
             <a:r>
-              <a:rPr sz="900" b="0" i="0">
+              <a:rPr sz="900" b="0" i="0" dirty="0">
                 <a:solidFill>
                   <a:srgbClr val="000000"/>
                 </a:solidFill>
                 <a:latin typeface="Segoe UI"/>
               </a:rPr>
-              <a:t>•  Inputs: user’s email/doc/Outlook text + opt-in personalization profile</a:t>
+              <a:t>•  Inputs: your email, document, Outlook message or a task you type — plus your opt-in profile</a:t>
             </a:r>
           </a:p>
           <a:p>
@@ -3646,13 +3887,13 @@
               </a:spcAft>
             </a:pPr>
             <a:r>
-              <a:rPr sz="900" b="0" i="0">
+              <a:rPr sz="900" b="0" i="0" dirty="0">
                 <a:solidFill>
                   <a:srgbClr val="000000"/>
                 </a:solidFill>
                 <a:latin typeface="Segoe UI"/>
               </a:rPr>
-              <a:t>•  Models: Azure OpenAI (GPT-5.5), hosted in your Azure tenant; behind a provider-agnostic, swappable interface</a:t>
+              <a:t>•  Models: Azure OpenAI (GPT-5.5), in your Azure tenant; provider-agnostic, swappable interface</a:t>
             </a:r>
           </a:p>
           <a:p>
@@ -3665,13 +3906,13 @@
               </a:spcAft>
             </a:pPr>
             <a:r>
-              <a:rPr sz="900" b="0" i="0">
+              <a:rPr sz="900" b="0" i="0" dirty="0">
                 <a:solidFill>
                   <a:srgbClr val="000000"/>
                 </a:solidFill>
                 <a:latin typeface="Segoe UI"/>
               </a:rPr>
-              <a:t>•  Outputs: summary, action items, deadlines, adaptive micro-steps + time estimates, dyslexia rewrite</a:t>
+              <a:t>•  Outputs: plain summary, action items, hidden deadlines, adaptive micro-steps + time estimates, dyslexia rewrite</a:t>
             </a:r>
           </a:p>
           <a:p>
@@ -3684,13 +3925,13 @@
               </a:spcAft>
             </a:pPr>
             <a:r>
-              <a:rPr sz="900" b="0" i="0">
+              <a:rPr sz="900" b="0" i="0" dirty="0">
                 <a:solidFill>
                   <a:srgbClr val="000000"/>
                 </a:solidFill>
                 <a:latin typeface="Segoe UI"/>
               </a:rPr>
-              <a:t>•  Guardrails: opt-in, no diagnosis, human-in-the-loop, data stays in tenant</a:t>
+              <a:t>•  Guardrails: privacy-first; no identity inference; opt-in (no diagnosis); human-in-the-loop; data never leaves your tenant</a:t>
             </a:r>
           </a:p>
         </p:txBody>
@@ -3703,8 +3944,8 @@
         </p:nvSpPr>
         <p:spPr>
           <a:xfrm>
-            <a:off x="4471416" y="4343400"/>
-            <a:ext cx="2889504" cy="2331720"/>
+            <a:off x="4471416" y="4626864"/>
+            <a:ext cx="2889504" cy="2139696"/>
           </a:xfrm>
           <a:prstGeom prst="rect">
             <a:avLst/>
@@ -3732,7 +3973,7 @@
           </a:fontRef>
         </p:style>
         <p:txBody>
-          <a:bodyPr rtlCol="0" anchor="t" wrap="square" lIns="109728" rIns="109728" tIns="54864" bIns="36576"/>
+          <a:bodyPr wrap="square" lIns="109728" rIns="109728" bIns="36576" rtlCol="0" anchor="t"/>
           <a:lstStyle/>
           <a:p>
             <a:pPr algn="l">
@@ -3744,9 +3985,9 @@
               </a:spcAft>
             </a:pPr>
             <a:r>
-              <a:rPr sz="1100" b="1" i="0">
-                <a:solidFill>
-                  <a:srgbClr val="FFFFFF"/>
+              <a:rPr sz="1100" b="1" i="0" dirty="0">
+                <a:solidFill>
+                  <a:schemeClr val="bg1"/>
                 </a:solidFill>
                 <a:latin typeface="Segoe UI"/>
               </a:rPr>
@@ -3759,17 +4000,17 @@
                 <a:spcPts val="0"/>
               </a:spcBef>
               <a:spcAft>
-                <a:spcPts val="300"/>
+                <a:spcPts val="400"/>
               </a:spcAft>
             </a:pPr>
             <a:r>
-              <a:rPr sz="950" b="0" i="0">
-                <a:solidFill>
-                  <a:srgbClr val="FFFFFF"/>
+              <a:rPr sz="900" b="0" i="0" dirty="0">
+                <a:solidFill>
+                  <a:schemeClr val="bg1"/>
                 </a:solidFill>
                 <a:latin typeface="Segoe UI"/>
               </a:rPr>
-              <a:t>•  Phase 1: Pilot with a neurodiversity ERG (1 business unit)</a:t>
+              <a:t>•  Phase 1: Pilot with a neurodiversity Employee Resource Group (ERG), in one business unit</a:t>
             </a:r>
           </a:p>
           <a:p>
@@ -3778,17 +4019,17 @@
                 <a:spcPts val="0"/>
               </a:spcBef>
               <a:spcAft>
-                <a:spcPts val="300"/>
+                <a:spcPts val="400"/>
               </a:spcAft>
             </a:pPr>
             <a:r>
-              <a:rPr sz="950" b="0" i="0">
-                <a:solidFill>
-                  <a:srgbClr val="FFFFFF"/>
+              <a:rPr sz="900" b="0" i="0" dirty="0">
+                <a:solidFill>
+                  <a:schemeClr val="bg1"/>
                 </a:solidFill>
                 <a:latin typeface="Segoe UI"/>
               </a:rPr>
-              <a:t>•  Phase 2: Org-wide on Azure; Outlook + Teams + Jira/ADO connectors</a:t>
+              <a:t>•  Phase 2: Org-wide on Azure; Outlook + Teams + Jira / Azure DevOps connectors</a:t>
             </a:r>
           </a:p>
           <a:p>
@@ -3797,17 +4038,35 @@
                 <a:spcPts val="0"/>
               </a:spcBef>
               <a:spcAft>
-                <a:spcPts val="300"/>
+                <a:spcPts val="400"/>
               </a:spcAft>
             </a:pPr>
             <a:r>
-              <a:rPr sz="950" b="0" i="0">
-                <a:solidFill>
-                  <a:srgbClr val="FFFFFF"/>
+              <a:rPr sz="900" b="0" i="0" dirty="0">
+                <a:solidFill>
+                  <a:schemeClr val="bg1"/>
                 </a:solidFill>
                 <a:latin typeface="Segoe UI"/>
               </a:rPr>
-              <a:t>•  Phase 3: More accessibility profiles (low-vision, language); privacy-safe manager insights</a:t>
+              <a:t>•  Phase 3: </a:t>
+            </a:r>
+            <a:r>
+              <a:rPr sz="900" b="0" i="0" dirty="0" err="1">
+                <a:solidFill>
+                  <a:schemeClr val="bg1"/>
+                </a:solidFill>
+                <a:latin typeface="Segoe UI"/>
+              </a:rPr>
+              <a:t>Behaviour</a:t>
+            </a:r>
+            <a:r>
+              <a:rPr sz="900" b="0" i="0" dirty="0">
+                <a:solidFill>
+                  <a:schemeClr val="bg1"/>
+                </a:solidFill>
+                <a:latin typeface="Segoe UI"/>
+              </a:rPr>
+              <a:t>-aware learning, agentic reminders &amp; escalation, more accessibility profiles (low-vision, more languages), privacy-safe manager insights — toward org-wide and external use</a:t>
             </a:r>
           </a:p>
         </p:txBody>
@@ -3820,8 +4079,8 @@
         </p:nvSpPr>
         <p:spPr>
           <a:xfrm>
-            <a:off x="8842248" y="4343400"/>
-            <a:ext cx="2889504" cy="2331720"/>
+            <a:off x="8842248" y="4626864"/>
+            <a:ext cx="2889504" cy="2139696"/>
           </a:xfrm>
           <a:prstGeom prst="rect">
             <a:avLst/>
@@ -3849,7 +4108,7 @@
           </a:fontRef>
         </p:style>
         <p:txBody>
-          <a:bodyPr rtlCol="0" anchor="t" wrap="square" lIns="109728" rIns="109728" tIns="54864" bIns="36576"/>
+          <a:bodyPr wrap="square" lIns="109728" rIns="109728" bIns="36576" rtlCol="0" anchor="t"/>
           <a:lstStyle/>
           <a:p>
             <a:pPr algn="l">
@@ -3861,7 +4120,7 @@
               </a:spcAft>
             </a:pPr>
             <a:r>
-              <a:rPr sz="1100" b="1" i="0">
+              <a:rPr sz="1100" b="1" i="0" dirty="0">
                 <a:solidFill>
                   <a:srgbClr val="FFFFFF"/>
                 </a:solidFill>
@@ -3876,17 +4135,17 @@
                 <a:spcPts val="0"/>
               </a:spcBef>
               <a:spcAft>
-                <a:spcPts val="300"/>
+                <a:spcPts val="400"/>
               </a:spcAft>
             </a:pPr>
             <a:r>
-              <a:rPr sz="950" b="0" i="0">
+              <a:rPr sz="900" b="0" i="0" dirty="0">
                 <a:solidFill>
                   <a:srgbClr val="FFFFFF"/>
                 </a:solidFill>
                 <a:latin typeface="Segoe UI"/>
               </a:rPr>
-              <a:t>•  Human-in-the-loop: AI is a draft; user edits &amp; approves; original source always one click away</a:t>
+              <a:t>•  Human-in-the-loop: every AI output is a draft you edit &amp; approve; the original source is one click away</a:t>
             </a:r>
           </a:p>
           <a:p>
@@ -3895,17 +4154,17 @@
                 <a:spcPts val="0"/>
               </a:spcBef>
               <a:spcAft>
-                <a:spcPts val="300"/>
+                <a:spcPts val="400"/>
               </a:spcAft>
             </a:pPr>
             <a:r>
-              <a:rPr sz="950" b="0" i="0">
+              <a:rPr sz="900" b="0" i="0" dirty="0">
                 <a:solidFill>
                   <a:srgbClr val="FFFFFF"/>
                 </a:solidFill>
                 <a:latin typeface="Segoe UI"/>
               </a:rPr>
-              <a:t>•  Personalization tested across profiles: same input → different, profile-correct output</a:t>
+              <a:t>•  Personalization tested across profiles: the same input gives different, profile-correct output</a:t>
             </a:r>
           </a:p>
           <a:p>
@@ -3914,17 +4173,17 @@
                 <a:spcPts val="0"/>
               </a:spcBef>
               <a:spcAft>
-                <a:spcPts val="300"/>
+                <a:spcPts val="400"/>
               </a:spcAft>
             </a:pPr>
             <a:r>
-              <a:rPr sz="950" b="0" i="0">
+              <a:rPr sz="900" b="0" i="0" dirty="0">
                 <a:solidFill>
                   <a:srgbClr val="FFFFFF"/>
                 </a:solidFill>
                 <a:latin typeface="Segoe UI"/>
               </a:rPr>
-              <a:t>•  Planned: task-quality review with ERG users; structured-output validation; latency/error monitoring</a:t>
+              <a:t>•  Not yet tested with end users — planned: task-quality review in the ERG pilot, structured-output checks, latency/error monitoring</a:t>
             </a:r>
           </a:p>
         </p:txBody>

</xml_diff>